<commit_message>
Business deck: replace flawed try-on screenshot with a working composite
The original demo used the black A-line dress (57049) on a model wearing
a wide pink dress: the underlying dress poked out around the composite,
and the 57049 cutout itself carries a hair-remnant blob that skews its
alpha bbox, shifting placement left. New screenshot: charcoal sweater
(23047) on a fitted-camisole model — clean placement, advice text
matches the visible result. Cutout defect in 57049/19728 flagged for a
separate repair pass.

Co-Authored-By: Claude Fable 5 <noreply@anthropic.com>
</commit_message>
<xml_diff>
--- a/submission/Debie_Galleros_Pillar5_CapstoneProject_BusinessDeck.pptx
+++ b/submission/Debie_Galleros_Pillar5_CapstoneProject_BusinessDeck.pptx
@@ -5404,7 +5404,7 @@
                 </a:solidFill>
                 <a:latin typeface="Arial"/>
               </a:rPr>
-              <a:t>The dress is placed on the shopper's own photo, scaled to their pose — picking a bigger size renders visibly bigger.</a:t>
+              <a:t>The sweater is placed on the shopper's own photo, scaled and angled to their pose — picking a bigger size renders visibly bigger.</a:t>
             </a:r>
           </a:p>
         </p:txBody>
@@ -5488,7 +5488,7 @@
                 </a:solidFill>
                 <a:latin typeface="Arial"/>
               </a:rPr>
-              <a:t>Plain words, no tailor talk: “the length falls just above your knee — a flattering, easy fit for you.”</a:t>
+              <a:t>Plain words, no tailor talk: “the length reaches your waist neatly, and the sleeves land well at your wrists.”</a:t>
             </a:r>
           </a:p>
         </p:txBody>

</xml_diff>

<commit_message>
Add demo video and fix report cover-page layout; commit report source
New: Debie_Galleros_Pillar5_CapstoneProject_DemoVideo.mp4, a six-page site walkthrough covering both privacy states across two catalog items. Report cover page: repository link on its own line, more space before Pillar 5 line. Also commits docs/report/build_report.py (report source) and docs/assets/eda/*.png (Figures 1-5) alongside the regenerated submission files.

Co-Authored-By: Claude Sonnet 5 <noreply@anthropic.com>
</commit_message>
<xml_diff>
--- a/submission/Debie_Galleros_Pillar5_CapstoneProject_BusinessDeck.pptx
+++ b/submission/Debie_Galleros_Pillar5_CapstoneProject_BusinessDeck.pptx
@@ -5530,7 +5530,7 @@
                 </a:solidFill>
                 <a:latin typeface="Arial"/>
               </a:rPr>
-              <a:t>Faces can be cropped out before the photo is ever saved; this screenshot shows the earlier blur-based safeguard instead.</a:t>
+              <a:t>The upper face (forehead, eyes) can be cropped out before the photo is ever saved, opt-in; this screenshot shows the earlier blur-based safeguard instead.</a:t>
             </a:r>
           </a:p>
         </p:txBody>
@@ -7596,7 +7596,7 @@
                 </a:solidFill>
                 <a:latin typeface="Arial"/>
               </a:rPr>
-              <a:t>An opt-in checkbox crops your face out before saving. Left unchecked, FitML still protects you — your real face is restored over anything the AI drew in its place.</a:t>
+              <a:t>An opt-in checkbox crops the upper face — forehead and eyes — out before saving. Left unchecked, FitML still protects you — your real face is restored over anything the AI drew in its place.</a:t>
             </a:r>
           </a:p>
         </p:txBody>

</xml_diff>

<commit_message>
Fix BusinessDeck slide 4: replace stale/blurred try-on screenshot
Slide 4 ("The virtual fitting room") showed an outdated blurred-face screenshot from the old privacy mechanism. Replaced with a fresh live render (real photo, crop-above-nose privacy path), retouched two IDM-VTON shoulder-seam rendering artifacts (thin skin-tone rim at the garment/background boundary) via OpenCV inpainting, and synced the caption text boxes (size, confidence, garment name, advice quote, privacy description) to match. Regenerated the combined submission PDF to carry the fix through.

Co-Authored-By: Claude Sonnet 5 <noreply@anthropic.com>
</commit_message>
<xml_diff>
--- a/submission/Debie_Galleros_Pillar5_CapstoneProject_BusinessDeck.pptx
+++ b/submission/Debie_Galleros_Pillar5_CapstoneProject_BusinessDeck.pptx
@@ -5091,22 +5091,22 @@
       </p:sp>
       <p:pic>
         <p:nvPicPr>
-          <p:cNvPr id="4" name="Picture 3" descr="item_tryon.png"/>
+          <p:cNvPr id="16" name="Picture 15" descr="final_clean.png"/>
           <p:cNvPicPr>
             <a:picLocks noChangeAspect="1"/>
           </p:cNvPicPr>
           <p:nvPr/>
         </p:nvPicPr>
         <p:blipFill>
-          <a:blip r:embed="rId3"/>
+          <a:blip r:embed="rId6"/>
           <a:stretch>
             <a:fillRect/>
           </a:stretch>
         </p:blipFill>
         <p:spPr>
           <a:xfrm>
-            <a:off x="502920" y="1874519"/>
-            <a:ext cx="6766560" cy="4229100"/>
+            <a:off x="1742622" y="1874519"/>
+            <a:ext cx="4287155" cy="4229100"/>
           </a:xfrm>
           <a:prstGeom prst="rect">
             <a:avLst/>
@@ -5121,8 +5121,8 @@
         </p:nvSpPr>
         <p:spPr>
           <a:xfrm>
-            <a:off x="502920" y="1874519"/>
-            <a:ext cx="6766560" cy="4229100"/>
+            <a:off x="1742622" y="1874519"/>
+            <a:ext cx="4287155" cy="4229100"/>
           </a:xfrm>
           <a:prstGeom prst="rect">
             <a:avLst/>
@@ -5278,7 +5278,7 @@
                 </a:solidFill>
                 <a:latin typeface="Arial"/>
               </a:rPr>
-              <a:t>“Recommended size: XS — 40% confidence” — the confidence level is shown, never hidden.</a:t>
+              <a:t>“Recommended size: M — 45% confidence” — the confidence level is shown, never hidden.</a:t>
             </a:r>
           </a:p>
         </p:txBody>
@@ -5362,7 +5362,7 @@
                 </a:solidFill>
                 <a:latin typeface="Arial"/>
               </a:rPr>
-              <a:t>The sweater is placed on the shopper's own photo, scaled and angled to their pose — picking a bigger size renders visibly bigger.</a:t>
+              <a:t>The blouse is placed on the shopper's own photo, scaled and angled to their pose — picking a bigger size renders visibly bigger.</a:t>
             </a:r>
           </a:p>
         </p:txBody>
@@ -5446,7 +5446,7 @@
                 </a:solidFill>
                 <a:latin typeface="Arial"/>
               </a:rPr>
-              <a:t>Plain words, no tailor talk: “the length reaches your waist neatly, and the sleeves land well at your wrists.”</a:t>
+              <a:t>Plain words, no tailor talk: “the short sleeves sit neatly on your arms, and the buttons run straight and even down the front.”</a:t>
             </a:r>
           </a:p>
         </p:txBody>
@@ -5530,7 +5530,7 @@
                 </a:solidFill>
                 <a:latin typeface="Arial"/>
               </a:rPr>
-              <a:t>The upper face (forehead, eyes) can be cropped out before the photo is ever saved, opt-in; this screenshot shows the earlier blur-based safeguard instead.</a:t>
+              <a:t>The upper face (forehead, eyes) can be cropped out before the photo is ever saved, opt-in — shown here live on the current site.</a:t>
             </a:r>
           </a:p>
         </p:txBody>

</xml_diff>

<commit_message>
Regenerate BusinessDeck slide 4: replace try-on screenshot with a working composite
Fresh render from the live site post-IDM-VTON-mask-fix and post-dress-sizing-fix deploy: United Colors of Benetton Women Solid White Shirt, recommended size XS at 40% confidence. Updated the four caption text boxes (recommendation, garment name, advice quote, privacy state) to match, and corrected the privacy caption to describe what the screenshot actually shows (default unchecked state, paste-back) rather than the crop feature. Regenerated the combined submission PDF to carry the fix through.

Co-Authored-By: Claude Sonnet 5 <noreply@anthropic.com>
</commit_message>
<xml_diff>
--- a/submission/Debie_Galleros_Pillar5_CapstoneProject_BusinessDeck.pptx
+++ b/submission/Debie_Galleros_Pillar5_CapstoneProject_BusinessDeck.pptx
@@ -5091,22 +5091,22 @@
       </p:sp>
       <p:pic>
         <p:nvPicPr>
-          <p:cNvPr id="16" name="Picture 15" descr="final_clean.png"/>
+          <p:cNvPr id="16" name="Picture 15" descr="deck_shirt.png"/>
           <p:cNvPicPr>
             <a:picLocks noChangeAspect="1"/>
           </p:cNvPicPr>
           <p:nvPr/>
         </p:nvPicPr>
         <p:blipFill>
-          <a:blip r:embed="rId6"/>
+          <a:blip r:embed="rId7"/>
           <a:stretch>
             <a:fillRect/>
           </a:stretch>
         </p:blipFill>
         <p:spPr>
           <a:xfrm>
-            <a:off x="1742622" y="1874519"/>
-            <a:ext cx="4287155" cy="4229100"/>
+            <a:off x="2300287" y="1874519"/>
+            <a:ext cx="3171825" cy="4229100"/>
           </a:xfrm>
           <a:prstGeom prst="rect">
             <a:avLst/>
@@ -5121,8 +5121,8 @@
         </p:nvSpPr>
         <p:spPr>
           <a:xfrm>
-            <a:off x="1742622" y="1874519"/>
-            <a:ext cx="4287155" cy="4229100"/>
+            <a:off x="2300287" y="1874519"/>
+            <a:ext cx="3171825" cy="4229100"/>
           </a:xfrm>
           <a:prstGeom prst="rect">
             <a:avLst/>
@@ -5278,7 +5278,7 @@
                 </a:solidFill>
                 <a:latin typeface="Arial"/>
               </a:rPr>
-              <a:t>“Recommended size: M — 45% confidence” — the confidence level is shown, never hidden.</a:t>
+              <a:t>“Recommended size: XS — 40% confidence” — the confidence level is shown, never hidden.</a:t>
             </a:r>
           </a:p>
         </p:txBody>
@@ -5362,7 +5362,7 @@
                 </a:solidFill>
                 <a:latin typeface="Arial"/>
               </a:rPr>
-              <a:t>The blouse is placed on the shopper's own photo, scaled and angled to their pose — picking a bigger size renders visibly bigger.</a:t>
+              <a:t>The shirt is placed on the shopper's own photo, scaled and angled to their pose — picking a bigger size renders visibly bigger.</a:t>
             </a:r>
           </a:p>
         </p:txBody>
@@ -5446,7 +5446,7 @@
                 </a:solidFill>
                 <a:latin typeface="Arial"/>
               </a:rPr>
-              <a:t>Plain words, no tailor talk: “the short sleeves sit neatly on your arms, and the buttons run straight and even down the front.”</a:t>
+              <a:t>Plain words, no tailor talk: “the length ends right at your waistband, and the sleeves fall neatly at your wrists.”</a:t>
             </a:r>
           </a:p>
         </p:txBody>
@@ -5530,7 +5530,7 @@
                 </a:solidFill>
                 <a:latin typeface="Arial"/>
               </a:rPr>
-              <a:t>The upper face (forehead, eyes) can be cropped out before the photo is ever saved, opt-in — shown here live on the current site.</a:t>
+              <a:t>The upper face (forehead, eyes) can be cropped out before the photo is ever saved, opt-in; this screenshot shows the default, unchecked state — the real face preserved via paste-back.</a:t>
             </a:r>
           </a:p>
         </p:txBody>

</xml_diff>